<commit_message>
fix: badge dai de len nhau (dong rong theo text + tu xuong dong), sua bug auto_size template + bug clone thu tu XML
</commit_message>
<xml_diff>
--- a/backend/app/export/assets/template.pptx
+++ b/backend/app/export/assets/template.pptx
@@ -3106,7 +3106,7 @@
         </p:spPr>
         <p:txBody>
           <a:bodyPr wrap="square">
-            <a:spAutoFit/>
+            <a:noAutofit/>
           </a:bodyPr>
           <a:lstStyle/>
           <a:p>
@@ -3162,7 +3162,7 @@
           </a:fontRef>
         </p:style>
         <p:txBody>
-          <a:bodyPr rtlCol="0" anchor="ctr" lIns="50800" rIns="50800" tIns="12700" bIns="12700"/>
+          <a:bodyPr rtlCol="0" anchor="ctr" lIns="50800" rIns="50800" tIns="12700" bIns="12700" wrap="none"/>
           <a:lstStyle/>
           <a:p>
             <a:pPr algn="ctr"/>
@@ -3217,7 +3217,7 @@
           </a:fontRef>
         </p:style>
         <p:txBody>
-          <a:bodyPr rtlCol="0" anchor="ctr" lIns="50800" rIns="50800" tIns="12700" bIns="12700"/>
+          <a:bodyPr rtlCol="0" anchor="ctr" lIns="50800" rIns="50800" tIns="12700" bIns="12700" wrap="none"/>
           <a:lstStyle/>
           <a:p>
             <a:pPr algn="ctr"/>
@@ -3330,7 +3330,7 @@
         </p:spPr>
         <p:txBody>
           <a:bodyPr wrap="square">
-            <a:spAutoFit/>
+            <a:normAutofit/>
           </a:bodyPr>
           <a:lstStyle/>
           <a:p>
@@ -3630,7 +3630,7 @@
         </p:spPr>
         <p:txBody>
           <a:bodyPr wrap="square">
-            <a:spAutoFit/>
+            <a:noAutofit/>
           </a:bodyPr>
           <a:lstStyle/>
           <a:p>
@@ -3686,7 +3686,7 @@
           </a:fontRef>
         </p:style>
         <p:txBody>
-          <a:bodyPr rtlCol="0" anchor="ctr" lIns="50800" rIns="50800" tIns="12700" bIns="12700"/>
+          <a:bodyPr rtlCol="0" anchor="ctr" lIns="50800" rIns="50800" tIns="12700" bIns="12700" wrap="none"/>
           <a:lstStyle/>
           <a:p>
             <a:pPr algn="ctr"/>
@@ -3741,7 +3741,7 @@
           </a:fontRef>
         </p:style>
         <p:txBody>
-          <a:bodyPr rtlCol="0" anchor="ctr" lIns="50800" rIns="50800" tIns="12700" bIns="12700"/>
+          <a:bodyPr rtlCol="0" anchor="ctr" lIns="50800" rIns="50800" tIns="12700" bIns="12700" wrap="none"/>
           <a:lstStyle/>
           <a:p>
             <a:pPr algn="ctr"/>
@@ -3775,7 +3775,7 @@
         </p:spPr>
         <p:txBody>
           <a:bodyPr wrap="square">
-            <a:spAutoFit/>
+            <a:noAutofit/>
           </a:bodyPr>
           <a:lstStyle/>
           <a:p>
@@ -3831,7 +3831,7 @@
           </a:fontRef>
         </p:style>
         <p:txBody>
-          <a:bodyPr rtlCol="0" anchor="ctr" lIns="50800" rIns="50800" tIns="12700" bIns="12700"/>
+          <a:bodyPr rtlCol="0" anchor="ctr" lIns="50800" rIns="50800" tIns="12700" bIns="12700" wrap="none"/>
           <a:lstStyle/>
           <a:p>
             <a:pPr algn="ctr"/>
@@ -3886,7 +3886,7 @@
           </a:fontRef>
         </p:style>
         <p:txBody>
-          <a:bodyPr rtlCol="0" anchor="ctr" lIns="50800" rIns="50800" tIns="12700" bIns="12700"/>
+          <a:bodyPr rtlCol="0" anchor="ctr" lIns="50800" rIns="50800" tIns="12700" bIns="12700" wrap="none"/>
           <a:lstStyle/>
           <a:p>
             <a:pPr algn="ctr"/>
@@ -3964,7 +3964,7 @@
         </p:spPr>
         <p:txBody>
           <a:bodyPr wrap="square">
-            <a:spAutoFit/>
+            <a:noAutofit/>
           </a:bodyPr>
           <a:lstStyle/>
           <a:p>

</xml_diff>